<commit_message>
Phase 9: Rescue & Reuse — Deck Decompiler + slide-library merge
- tools/decompile.py: any .pptx -> spec.json (chart data, stat strips
  paired by column geometry, kicker capture, picture extraction,
  anatomy theme as overrides); QBR rescue retains ~95% of words,
  regenerated deck QA GREEN, diff.py measures the delta
- Rescuing exposed a LATENT BUG: s_title/s_closing ignored
  `title_lines`, so Wizard/Drafter/bilingual decks leaked the default
  "Presentation Title". Builders now accept title_lines as an alias;
  QA gained a placeholder-leak FAIL check; bilingual demo rebuilt
- tools/merge.py: cherry-pick slides across decks (OPC part surgery —
  charts + embedded xlsx verified readable after transplant), notes
  and backgrounds travel, --morph re-stamps transitions
- +4 tests (24 total): alias, placeholder, decompile round-trip, merge

Co-authored-by: arena-agent <297053741+arena-agent@users.noreply.github.com>
</commit_message>
<xml_diff>
--- a/examples/arabic-bilingual-demo.pptx
+++ b/examples/arabic-bilingual-demo.pptx
@@ -4255,7 +4255,7 @@
                 </a:solidFill>
                 <a:latin typeface="Cairo"/>
               </a:rPr>
-              <a:t>Presentation Title</a:t>
+              <a:t>منصة وصل</a:t>
             </a:r>
           </a:p>
         </p:txBody>
@@ -6485,7 +6485,7 @@
                 </a:solidFill>
                 <a:latin typeface="Cairo"/>
               </a:rPr>
-              <a:t>Thank you</a:t>
+              <a:t>نغلق الحلقة معا</a:t>
             </a:r>
           </a:p>
         </p:txBody>

</xml_diff>